<commit_message>
Use readable IEEE-size figure labels in the paper and English slides
</commit_message>
<xml_diff>
--- a/paper_icdm/output/final_presentation_en.pptx
+++ b/paper_icdm/output/final_presentation_en.pptx
@@ -5132,8 +5132,8 @@
         </p:blipFill>
         <p:spPr>
           <a:xfrm>
-            <a:off x="2852487" y="1627632"/>
-            <a:ext cx="6456544" cy="4343400"/>
+            <a:off x="3365579" y="1627632"/>
+            <a:ext cx="5430361" cy="4343400"/>
           </a:xfrm>
           <a:prstGeom prst="rect">
             <a:avLst/>
@@ -9427,8 +9427,8 @@
         </p:blipFill>
         <p:spPr>
           <a:xfrm>
-            <a:off x="2383245" y="1755648"/>
-            <a:ext cx="7395029" cy="3493007"/>
+            <a:off x="2811256" y="1755648"/>
+            <a:ext cx="6539007" cy="3493008"/>
           </a:xfrm>
           <a:prstGeom prst="rect">
             <a:avLst/>

</xml_diff>